<commit_message>
Sync pptx content with the HTML deck
Adds the CBN June 10, 2026 cyber-framework deadline to the Cybercrimes Act
slide (replacing the offences/levy row, matching the HTML deck), named
pull-quotes from Lanre Ogungbe (AI slide) and Adewale Odunsi (case-study
slide), and the closing bridge line on Key Takeaways — so both formats say
the same thing.
</commit_message>
<xml_diff>
--- a/Cybersecurity_Trends_in_Nigeria.pptx
+++ b/Cybersecurity_Trends_in_Nigeria.pptx
@@ -1582,7 +1582,7 @@
           <a:p>
             <a:r>
               <a:rPr lang="en-US" dirty="0"/>
-              <a:t>Signed February 2024, this amendment updates Nigeria's original 2015 cybercrime law. Four provisions matter most for organizations: first, a mandatory 72-hour window to report any attack or intrusion to the National CERT. Second, service providers now must retain traffic and subscriber data for two years. Third - and this is the controversial one - security agencies gained expanded power to intercept communications without a court order in urgent situations, which has drawn civil-liberties criticism. Fourth, new offences around cyberstalking and disinformation, plus a cybersecurity levy that adds to the cost of doing business. Net effect: compliance obligations just got a lot more concrete. (~55 sec)</a:t>
+              <a:t>Signed February 2024, this amendment updates Nigeria's original 2015 cybercrime law. Four provisions matter most for organizations: first, a mandatory 72-hour window to report any attack or intrusion to the National CERT. Second, service providers now must retain traffic and subscriber data for two years. Third - and this is the controversial one - security agencies gained expanded power to intercept communications without a court order in urgent situations, which has drawn civil-liberties criticism. On top of that, the CBN now requires every regulated bank to submit a cybersecurity implementation roadmap by June 10, 2026 - and most Nigerian banks still don't have a CISO to write one. Net effect: compliance obligations just got a lot more concrete, on multiple fronts at once. (~60 sec)</a:t>
             </a:r>
             <a:endParaRPr lang="en-US" dirty="0"/>
           </a:p>
@@ -1846,7 +1846,7 @@
           <a:p>
             <a:r>
               <a:rPr lang="en-US" dirty="0"/>
-              <a:t>Five takeaways to carry out of this room. One: attacks are more frequent, more automated with AI, and increasingly about stealing identity rather than just disrupting systems. Two: regulation has real teeth now - NDPC fines and the 72-hour reporting rule mean compliance is a genuine operational requirement, not paperwork. Three: critical infrastructure is the top target, and the CAC breach shows how one vulnerability can cascade across an entire economy. Four: the talent shortage is the binding constraint underneath all of this - you can't buy your way out of a people problem. Five: the direction of travel for defense is zero-trust, identity-first security, and real information sharing across sectors. That's the briefing - happy to open it up. (~60 sec)</a:t>
+              <a:t>Five takeaways to carry out of this room. One: attacks are more frequent, more automated with AI, and increasingly about stealing identity rather than just disrupting systems. Two: regulation has real teeth now - NDPC fines, the 72-hour reporting rule, and the CBN's June 2026 deadline mean compliance is a genuine operational requirement, not paperwork. Three: critical infrastructure is the top target, and the CAC breach shows how one vulnerability can cascade across an entire economy. Four: the talent shortage is the binding constraint underneath all of this - you can't buy your way out of a people problem. Five: the direction of travel for defense is zero-trust, identity-first security, and real information sharing across sectors. Close on the bridge line - this is the moment to connect the material back to why you're in this interview. Say it, then pause and open the floor. (~65 sec)</a:t>
             </a:r>
             <a:endParaRPr lang="en-US" dirty="0"/>
           </a:p>
@@ -5444,7 +5444,7 @@
                 <a:ea typeface="Calibri" pitchFamily="34" charset="-122"/>
                 <a:cs typeface="Calibri" pitchFamily="34" charset="-120"/>
               </a:rPr>
-              <a:t>New offences &amp; levy</a:t>
+              <a:t>CBN cyber-framework deadline</a:t>
             </a:r>
             <a:endParaRPr lang="en-US" sz="1400" dirty="0"/>
           </a:p>
@@ -5483,7 +5483,7 @@
                 <a:ea typeface="Calibri" pitchFamily="34" charset="-122"/>
                 <a:cs typeface="Calibri" pitchFamily="34" charset="-120"/>
               </a:rPr>
-              <a:t>New cyberstalking / disinformation offences, plus a cybersecurity levy that raises compliance costs</a:t>
+              <a:t>Every regulated bank must submit an implementation roadmap by June 10, 2026 — most still lack a CISO to write one</a:t>
             </a:r>
             <a:endParaRPr lang="en-US" sz="1200" dirty="0"/>
           </a:p>
@@ -6954,8 +6954,8 @@
         </p:nvSpPr>
         <p:spPr>
           <a:xfrm>
-            <a:off x="502920" y="1764792"/>
-            <a:ext cx="457200" cy="457200"/>
+            <a:off x="502920" y="1709928"/>
+            <a:ext cx="402336" cy="402336"/>
           </a:xfrm>
           <a:prstGeom prst="ellipse">
             <a:avLst/>
@@ -6974,8 +6974,8 @@
         </p:nvSpPr>
         <p:spPr>
           <a:xfrm>
-            <a:off x="502920" y="1764792"/>
-            <a:ext cx="457200" cy="457200"/>
+            <a:off x="502920" y="1709928"/>
+            <a:ext cx="402336" cy="402336"/>
           </a:xfrm>
           <a:prstGeom prst="rect">
             <a:avLst/>
@@ -6991,7 +6991,7 @@
               <a:buNone/>
             </a:pPr>
             <a:r>
-              <a:rPr lang="en-US" sz="1800" b="1" dirty="0">
+              <a:rPr lang="en-US" sz="1600" b="1" dirty="0">
                 <a:solidFill>
                   <a:srgbClr val="073821"/>
                 </a:solidFill>
@@ -7001,7 +7001,7 @@
               </a:rPr>
               <a:t>1</a:t>
             </a:r>
-            <a:endParaRPr lang="en-US" sz="1800" dirty="0"/>
+            <a:endParaRPr lang="en-US" sz="1600" dirty="0"/>
           </a:p>
         </p:txBody>
       </p:sp>
@@ -7013,8 +7013,8 @@
         </p:nvSpPr>
         <p:spPr>
           <a:xfrm>
-            <a:off x="1188720" y="1737360"/>
-            <a:ext cx="10500055" cy="749808"/>
+            <a:off x="1124712" y="1691640"/>
+            <a:ext cx="10564063" cy="694944"/>
           </a:xfrm>
           <a:prstGeom prst="rect">
             <a:avLst/>
@@ -7030,7 +7030,7 @@
               <a:buNone/>
             </a:pPr>
             <a:r>
-              <a:rPr lang="en-US" sz="1500" dirty="0">
+              <a:rPr lang="en-US" sz="1350" dirty="0">
                 <a:solidFill>
                   <a:srgbClr val="F0F6F2"/>
                 </a:solidFill>
@@ -7040,7 +7040,7 @@
               </a:rPr>
               <a:t>Attacks are more frequent, more automated (AI-assisted), and increasingly identity-focused.</a:t>
             </a:r>
-            <a:endParaRPr lang="en-US" sz="1500" dirty="0"/>
+            <a:endParaRPr lang="en-US" sz="1350" dirty="0"/>
           </a:p>
         </p:txBody>
       </p:sp>
@@ -7052,8 +7052,8 @@
         </p:nvSpPr>
         <p:spPr>
           <a:xfrm>
-            <a:off x="502920" y="2606040"/>
-            <a:ext cx="457200" cy="457200"/>
+            <a:off x="502920" y="2459736"/>
+            <a:ext cx="402336" cy="402336"/>
           </a:xfrm>
           <a:prstGeom prst="ellipse">
             <a:avLst/>
@@ -7072,8 +7072,8 @@
         </p:nvSpPr>
         <p:spPr>
           <a:xfrm>
-            <a:off x="502920" y="2606040"/>
-            <a:ext cx="457200" cy="457200"/>
+            <a:off x="502920" y="2459736"/>
+            <a:ext cx="402336" cy="402336"/>
           </a:xfrm>
           <a:prstGeom prst="rect">
             <a:avLst/>
@@ -7089,7 +7089,7 @@
               <a:buNone/>
             </a:pPr>
             <a:r>
-              <a:rPr lang="en-US" sz="1800" b="1" dirty="0">
+              <a:rPr lang="en-US" sz="1600" b="1" dirty="0">
                 <a:solidFill>
                   <a:srgbClr val="073821"/>
                 </a:solidFill>
@@ -7099,7 +7099,7 @@
               </a:rPr>
               <a:t>2</a:t>
             </a:r>
-            <a:endParaRPr lang="en-US" sz="1800" dirty="0"/>
+            <a:endParaRPr lang="en-US" sz="1600" dirty="0"/>
           </a:p>
         </p:txBody>
       </p:sp>
@@ -7111,8 +7111,8 @@
         </p:nvSpPr>
         <p:spPr>
           <a:xfrm>
-            <a:off x="1188720" y="2578608"/>
-            <a:ext cx="10500055" cy="749808"/>
+            <a:off x="1124712" y="2441448"/>
+            <a:ext cx="10564063" cy="694944"/>
           </a:xfrm>
           <a:prstGeom prst="rect">
             <a:avLst/>
@@ -7128,7 +7128,7 @@
               <a:buNone/>
             </a:pPr>
             <a:r>
-              <a:rPr lang="en-US" sz="1500" dirty="0">
+              <a:rPr lang="en-US" sz="1350" dirty="0">
                 <a:solidFill>
                   <a:srgbClr val="F0F6F2"/>
                 </a:solidFill>
@@ -7138,7 +7138,7 @@
               </a:rPr>
               <a:t>Regulation now has real teeth — NDPC fines and 72-hour reporting mean compliance is no longer optional.</a:t>
             </a:r>
-            <a:endParaRPr lang="en-US" sz="1500" dirty="0"/>
+            <a:endParaRPr lang="en-US" sz="1350" dirty="0"/>
           </a:p>
         </p:txBody>
       </p:sp>
@@ -7150,8 +7150,8 @@
         </p:nvSpPr>
         <p:spPr>
           <a:xfrm>
-            <a:off x="502920" y="3447288"/>
-            <a:ext cx="457200" cy="457200"/>
+            <a:off x="502920" y="3209544"/>
+            <a:ext cx="402336" cy="402336"/>
           </a:xfrm>
           <a:prstGeom prst="ellipse">
             <a:avLst/>
@@ -7170,8 +7170,8 @@
         </p:nvSpPr>
         <p:spPr>
           <a:xfrm>
-            <a:off x="502920" y="3447288"/>
-            <a:ext cx="457200" cy="457200"/>
+            <a:off x="502920" y="3209544"/>
+            <a:ext cx="402336" cy="402336"/>
           </a:xfrm>
           <a:prstGeom prst="rect">
             <a:avLst/>
@@ -7187,7 +7187,7 @@
               <a:buNone/>
             </a:pPr>
             <a:r>
-              <a:rPr lang="en-US" sz="1800" b="1" dirty="0">
+              <a:rPr lang="en-US" sz="1600" b="1" dirty="0">
                 <a:solidFill>
                   <a:srgbClr val="073821"/>
                 </a:solidFill>
@@ -7197,7 +7197,7 @@
               </a:rPr>
               <a:t>3</a:t>
             </a:r>
-            <a:endParaRPr lang="en-US" sz="1800" dirty="0"/>
+            <a:endParaRPr lang="en-US" sz="1600" dirty="0"/>
           </a:p>
         </p:txBody>
       </p:sp>
@@ -7209,8 +7209,8 @@
         </p:nvSpPr>
         <p:spPr>
           <a:xfrm>
-            <a:off x="1188720" y="3419856"/>
-            <a:ext cx="10500055" cy="749808"/>
+            <a:off x="1124712" y="3191256"/>
+            <a:ext cx="10564063" cy="694944"/>
           </a:xfrm>
           <a:prstGeom prst="rect">
             <a:avLst/>
@@ -7226,7 +7226,7 @@
               <a:buNone/>
             </a:pPr>
             <a:r>
-              <a:rPr lang="en-US" sz="1500" dirty="0">
+              <a:rPr lang="en-US" sz="1350" dirty="0">
                 <a:solidFill>
                   <a:srgbClr val="F0F6F2"/>
                 </a:solidFill>
@@ -7236,7 +7236,7 @@
               </a:rPr>
               <a:t>Critical infrastructure is a top target — a single vulnerability (like the CAC breach) can cascade nationally.</a:t>
             </a:r>
-            <a:endParaRPr lang="en-US" sz="1500" dirty="0"/>
+            <a:endParaRPr lang="en-US" sz="1350" dirty="0"/>
           </a:p>
         </p:txBody>
       </p:sp>
@@ -7248,8 +7248,8 @@
         </p:nvSpPr>
         <p:spPr>
           <a:xfrm>
-            <a:off x="502920" y="4288536"/>
-            <a:ext cx="457200" cy="457200"/>
+            <a:off x="502920" y="3959352"/>
+            <a:ext cx="402336" cy="402336"/>
           </a:xfrm>
           <a:prstGeom prst="ellipse">
             <a:avLst/>
@@ -7268,8 +7268,8 @@
         </p:nvSpPr>
         <p:spPr>
           <a:xfrm>
-            <a:off x="502920" y="4288536"/>
-            <a:ext cx="457200" cy="457200"/>
+            <a:off x="502920" y="3959352"/>
+            <a:ext cx="402336" cy="402336"/>
           </a:xfrm>
           <a:prstGeom prst="rect">
             <a:avLst/>
@@ -7285,7 +7285,7 @@
               <a:buNone/>
             </a:pPr>
             <a:r>
-              <a:rPr lang="en-US" sz="1800" b="1" dirty="0">
+              <a:rPr lang="en-US" sz="1600" b="1" dirty="0">
                 <a:solidFill>
                   <a:srgbClr val="073821"/>
                 </a:solidFill>
@@ -7295,7 +7295,7 @@
               </a:rPr>
               <a:t>4</a:t>
             </a:r>
-            <a:endParaRPr lang="en-US" sz="1800" dirty="0"/>
+            <a:endParaRPr lang="en-US" sz="1600" dirty="0"/>
           </a:p>
         </p:txBody>
       </p:sp>
@@ -7307,8 +7307,8 @@
         </p:nvSpPr>
         <p:spPr>
           <a:xfrm>
-            <a:off x="1188720" y="4261104"/>
-            <a:ext cx="10500055" cy="749808"/>
+            <a:off x="1124712" y="3941064"/>
+            <a:ext cx="10564063" cy="694944"/>
           </a:xfrm>
           <a:prstGeom prst="rect">
             <a:avLst/>
@@ -7324,7 +7324,7 @@
               <a:buNone/>
             </a:pPr>
             <a:r>
-              <a:rPr lang="en-US" sz="1500" dirty="0">
+              <a:rPr lang="en-US" sz="1350" dirty="0">
                 <a:solidFill>
                   <a:srgbClr val="F0F6F2"/>
                 </a:solidFill>
@@ -7334,7 +7334,7 @@
               </a:rPr>
               <a:t>The talent shortage is the binding constraint — tooling and law can’t outrun a lack of skilled defenders.</a:t>
             </a:r>
-            <a:endParaRPr lang="en-US" sz="1500" dirty="0"/>
+            <a:endParaRPr lang="en-US" sz="1350" dirty="0"/>
           </a:p>
         </p:txBody>
       </p:sp>
@@ -7346,8 +7346,8 @@
         </p:nvSpPr>
         <p:spPr>
           <a:xfrm>
-            <a:off x="502920" y="5129784"/>
-            <a:ext cx="457200" cy="457200"/>
+            <a:off x="502920" y="4709160"/>
+            <a:ext cx="402336" cy="402336"/>
           </a:xfrm>
           <a:prstGeom prst="ellipse">
             <a:avLst/>
@@ -7366,8 +7366,8 @@
         </p:nvSpPr>
         <p:spPr>
           <a:xfrm>
-            <a:off x="502920" y="5129784"/>
-            <a:ext cx="457200" cy="457200"/>
+            <a:off x="502920" y="4709160"/>
+            <a:ext cx="402336" cy="402336"/>
           </a:xfrm>
           <a:prstGeom prst="rect">
             <a:avLst/>
@@ -7383,7 +7383,7 @@
               <a:buNone/>
             </a:pPr>
             <a:r>
-              <a:rPr lang="en-US" sz="1800" b="1" dirty="0">
+              <a:rPr lang="en-US" sz="1600" b="1" dirty="0">
                 <a:solidFill>
                   <a:srgbClr val="073821"/>
                 </a:solidFill>
@@ -7393,7 +7393,7 @@
               </a:rPr>
               <a:t>5</a:t>
             </a:r>
-            <a:endParaRPr lang="en-US" sz="1800" dirty="0"/>
+            <a:endParaRPr lang="en-US" sz="1600" dirty="0"/>
           </a:p>
         </p:txBody>
       </p:sp>
@@ -7405,8 +7405,8 @@
         </p:nvSpPr>
         <p:spPr>
           <a:xfrm>
-            <a:off x="1188720" y="5102352"/>
-            <a:ext cx="10500055" cy="749808"/>
+            <a:off x="1124712" y="4690872"/>
+            <a:ext cx="10564063" cy="694944"/>
           </a:xfrm>
           <a:prstGeom prst="rect">
             <a:avLst/>
@@ -7422,7 +7422,7 @@
               <a:buNone/>
             </a:pPr>
             <a:r>
-              <a:rPr lang="en-US" sz="1500" dirty="0">
+              <a:rPr lang="en-US" sz="1350" dirty="0">
                 <a:solidFill>
                   <a:srgbClr val="F0F6F2"/>
                 </a:solidFill>
@@ -7432,13 +7432,88 @@
               </a:rPr>
               <a:t>Zero-trust, identity-first defense, and cross-sector information sharing are the direction of travel.</a:t>
             </a:r>
-            <a:endParaRPr lang="en-US" sz="1500" dirty="0"/>
-          </a:p>
-        </p:txBody>
-      </p:sp>
-      <p:sp>
-        <p:nvSpPr>
-          <p:cNvPr id="19" name="Text 17"/>
+            <a:endParaRPr lang="en-US" sz="1350" dirty="0"/>
+          </a:p>
+        </p:txBody>
+      </p:sp>
+      <p:sp>
+        <p:nvSpPr>
+          <p:cNvPr id="19" name="Shape 17"/>
+          <p:cNvSpPr/>
+          <p:nvPr/>
+        </p:nvSpPr>
+        <p:spPr>
+          <a:xfrm>
+            <a:off x="502920" y="5568696"/>
+            <a:ext cx="11185855" cy="777240"/>
+          </a:xfrm>
+          <a:prstGeom prst="roundRect">
+            <a:avLst>
+              <a:gd name="adj" fmla="val 9412"/>
+            </a:avLst>
+          </a:prstGeom>
+          <a:solidFill>
+            <a:srgbClr val="0B5E34"/>
+          </a:solidFill>
+          <a:ln/>
+        </p:spPr>
+      </p:sp>
+      <p:sp>
+        <p:nvSpPr>
+          <p:cNvPr id="20" name="Text 18"/>
+          <p:cNvSpPr/>
+          <p:nvPr/>
+        </p:nvSpPr>
+        <p:spPr>
+          <a:xfrm>
+            <a:off x="777240" y="5568696"/>
+            <a:ext cx="10637215" cy="777240"/>
+          </a:xfrm>
+          <a:prstGeom prst="rect">
+            <a:avLst/>
+          </a:prstGeom>
+          <a:noFill/>
+          <a:ln/>
+        </p:spPr>
+        <p:txBody>
+          <a:bodyPr wrap="square" lIns="0" tIns="0" rIns="0" bIns="0" rtlCol="0" anchor="ctr"/>
+          <a:lstStyle/>
+          <a:p>
+            <a:pPr indent="0" marL="0">
+              <a:buNone/>
+            </a:pPr>
+            <a:r>
+              <a:rPr lang="en-US" sz="1450" i="1" dirty="0">
+                <a:solidFill>
+                  <a:srgbClr val="FFFFFF"/>
+                </a:solidFill>
+                <a:latin typeface="Cambria" pitchFamily="34" charset="0"/>
+                <a:ea typeface="Cambria" pitchFamily="34" charset="-122"/>
+                <a:cs typeface="Cambria" pitchFamily="34" charset="-120"/>
+              </a:rPr>
+              <a:t>“Understanding this landscape isn’t academic for me — it’s the market I want to help Sophos defend.” </a:t>
+            </a:r>
+            <a:pPr indent="0" marL="0">
+              <a:buNone/>
+            </a:pPr>
+            <a:r>
+              <a:rPr lang="en-US" sz="1450" b="1" dirty="0">
+                <a:solidFill>
+                  <a:srgbClr val="E8A93A"/>
+                </a:solidFill>
+                <a:latin typeface="Cambria" pitchFamily="34" charset="0"/>
+                <a:ea typeface="Cambria" pitchFamily="34" charset="-122"/>
+                <a:cs typeface="Cambria" pitchFamily="34" charset="-120"/>
+              </a:rPr>
+              <a:t>— Kelechi</a:t>
+            </a:r>
+            <a:endParaRPr lang="en-US" sz="1450" dirty="0"/>
+          </a:p>
+        </p:txBody>
+      </p:sp>
+      <p:sp>
+        <p:nvSpPr>
+          <p:cNvPr id="21" name="Text 19"/>
           <p:cNvSpPr/>
           <p:nvPr/>
         </p:nvSpPr>
@@ -12777,7 +12852,7 @@
         </p:nvSpPr>
         <p:spPr>
           <a:xfrm>
-            <a:off x="502920" y="5797296"/>
+            <a:off x="502920" y="5779008"/>
             <a:ext cx="11185855" cy="365760"/>
           </a:xfrm>
           <a:prstGeom prst="rect">
@@ -12802,7 +12877,21 @@
                 <a:ea typeface="Calibri" pitchFamily="34" charset="-122"/>
                 <a:cs typeface="Calibri" pitchFamily="34" charset="-120"/>
               </a:rPr>
-              <a:t>AI-driven phishing and impersonation are projected to intensify ~70% in 2026 — the fastest-moving trend in this briefing.</a:t>
+              <a:t>“AI-driven attacks on the financial sector surged 150% last year.” </a:t>
+            </a:r>
+            <a:pPr indent="0" marL="0">
+              <a:buNone/>
+            </a:pPr>
+            <a:r>
+              <a:rPr lang="en-US" sz="1250" dirty="0">
+                <a:solidFill>
+                  <a:srgbClr val="5E6E66"/>
+                </a:solidFill>
+                <a:latin typeface="Calibri" pitchFamily="34" charset="0"/>
+                <a:ea typeface="Calibri" pitchFamily="34" charset="-122"/>
+                <a:cs typeface="Calibri" pitchFamily="34" charset="-120"/>
+              </a:rPr>
+              <a:t>— Lanre Ogungbe, CEO, Prembly</a:t>
             </a:r>
             <a:endParaRPr lang="en-US" sz="1250" dirty="0"/>
           </a:p>
@@ -13305,7 +13394,7 @@
         <p:spPr>
           <a:xfrm>
             <a:off x="502920" y="3703320"/>
-            <a:ext cx="11185855" cy="2011680"/>
+            <a:ext cx="6400800" cy="2286000"/>
           </a:xfrm>
           <a:prstGeom prst="rect">
             <a:avLst/>
@@ -13319,16 +13408,16 @@
           <a:p>
             <a:pPr marL="228600" indent="-228600">
               <a:lnSpc>
-                <a:spcPts val="1664"/>
+                <a:spcPts val="1600"/>
               </a:lnSpc>
               <a:spcAft>
-                <a:spcPts val="900"/>
+                <a:spcPts val="1000"/>
               </a:spcAft>
               <a:buSzPct val="100000"/>
               <a:buChar char="▪"/>
             </a:pPr>
             <a:r>
-              <a:rPr lang="en-US" sz="1300" dirty="0">
+              <a:rPr lang="en-US" sz="1250" dirty="0">
                 <a:solidFill>
                   <a:srgbClr val="E9F2EC"/>
                 </a:solidFill>
@@ -13338,21 +13427,21 @@
               </a:rPr>
               <a:t>Banks, courts, and the EFCC all rely on CAC records for due diligence and fraud investigation — the breach undermines national anti-money-laundering reforms.</a:t>
             </a:r>
-            <a:endParaRPr lang="en-US" sz="1300" dirty="0"/>
+            <a:endParaRPr lang="en-US" sz="1250" dirty="0"/>
           </a:p>
           <a:p>
             <a:pPr marL="228600" indent="-228600">
               <a:lnSpc>
-                <a:spcPts val="1664"/>
+                <a:spcPts val="1600"/>
               </a:lnSpc>
               <a:spcAft>
-                <a:spcPts val="900"/>
+                <a:spcPts val="1000"/>
               </a:spcAft>
               <a:buSzPct val="100000"/>
               <a:buChar char="▪"/>
             </a:pPr>
             <a:r>
-              <a:rPr lang="en-US" sz="1300" dirty="0">
+              <a:rPr lang="en-US" sz="1250" dirty="0">
                 <a:solidFill>
                   <a:srgbClr val="E9F2EC"/>
                 </a:solidFill>
@@ -13362,21 +13451,21 @@
               </a:rPr>
               <a:t>CAC shut down its company-registration portal to contain the damage; the NDPC opened a full investigation.</a:t>
             </a:r>
-            <a:endParaRPr lang="en-US" sz="1300" dirty="0"/>
+            <a:endParaRPr lang="en-US" sz="1250" dirty="0"/>
           </a:p>
           <a:p>
             <a:pPr marL="228600" indent="-228600">
               <a:lnSpc>
-                <a:spcPts val="1664"/>
+                <a:spcPts val="1600"/>
               </a:lnSpc>
               <a:spcAft>
-                <a:spcPts val="900"/>
+                <a:spcPts val="1000"/>
               </a:spcAft>
               <a:buSzPct val="100000"/>
               <a:buChar char="▪"/>
             </a:pPr>
             <a:r>
-              <a:rPr lang="en-US" sz="1300" dirty="0">
+              <a:rPr lang="en-US" sz="1250" dirty="0">
                 <a:solidFill>
                   <a:srgbClr val="E9F2EC"/>
                 </a:solidFill>
@@ -13386,13 +13475,113 @@
               </a:rPr>
               <a:t>ByteToBreach specializes in stealing and selling data rather than encrypting it — a shift from classic ransomware to data-theft-and-extortion.</a:t>
             </a:r>
-            <a:endParaRPr lang="en-US" sz="1300" dirty="0"/>
-          </a:p>
-        </p:txBody>
-      </p:sp>
-      <p:sp>
-        <p:nvSpPr>
-          <p:cNvPr id="15" name="Text 13"/>
+            <a:endParaRPr lang="en-US" sz="1250" dirty="0"/>
+          </a:p>
+        </p:txBody>
+      </p:sp>
+      <p:sp>
+        <p:nvSpPr>
+          <p:cNvPr id="15" name="Shape 13"/>
+          <p:cNvSpPr/>
+          <p:nvPr/>
+        </p:nvSpPr>
+        <p:spPr>
+          <a:xfrm>
+            <a:off x="7086600" y="3703320"/>
+            <a:ext cx="4297680" cy="2103120"/>
+          </a:xfrm>
+          <a:prstGeom prst="roundRect">
+            <a:avLst>
+              <a:gd name="adj" fmla="val 4348"/>
+            </a:avLst>
+          </a:prstGeom>
+          <a:solidFill>
+            <a:srgbClr val="0B5E34"/>
+          </a:solidFill>
+          <a:ln/>
+        </p:spPr>
+      </p:sp>
+      <p:sp>
+        <p:nvSpPr>
+          <p:cNvPr id="16" name="Text 14"/>
+          <p:cNvSpPr/>
+          <p:nvPr/>
+        </p:nvSpPr>
+        <p:spPr>
+          <a:xfrm>
+            <a:off x="7315200" y="3931920"/>
+            <a:ext cx="3840480" cy="1280160"/>
+          </a:xfrm>
+          <a:prstGeom prst="rect">
+            <a:avLst/>
+          </a:prstGeom>
+          <a:noFill/>
+          <a:ln/>
+        </p:spPr>
+        <p:txBody>
+          <a:bodyPr wrap="square" lIns="0" tIns="0" rIns="0" bIns="0" rtlCol="0" anchor="t"/>
+          <a:lstStyle/>
+          <a:p>
+            <a:pPr indent="0" marL="0">
+              <a:buNone/>
+            </a:pPr>
+            <a:r>
+              <a:rPr lang="en-US" sz="1400" i="1" dirty="0">
+                <a:solidFill>
+                  <a:srgbClr val="FFFFFF"/>
+                </a:solidFill>
+                <a:latin typeface="Cambria" pitchFamily="34" charset="0"/>
+                <a:ea typeface="Cambria" pitchFamily="34" charset="-122"/>
+                <a:cs typeface="Cambria" pitchFamily="34" charset="-120"/>
+              </a:rPr>
+              <a:t>“These are coordinated operations targeting identity systems, financial rails and national databases.”</a:t>
+            </a:r>
+            <a:endParaRPr lang="en-US" sz="1400" dirty="0"/>
+          </a:p>
+        </p:txBody>
+      </p:sp>
+      <p:sp>
+        <p:nvSpPr>
+          <p:cNvPr id="17" name="Text 15"/>
+          <p:cNvSpPr/>
+          <p:nvPr/>
+        </p:nvSpPr>
+        <p:spPr>
+          <a:xfrm>
+            <a:off x="7315200" y="5349240"/>
+            <a:ext cx="3840480" cy="320040"/>
+          </a:xfrm>
+          <a:prstGeom prst="rect">
+            <a:avLst/>
+          </a:prstGeom>
+          <a:noFill/>
+          <a:ln/>
+        </p:spPr>
+        <p:txBody>
+          <a:bodyPr wrap="square" lIns="0" tIns="0" rIns="0" bIns="0" rtlCol="0" anchor="ctr"/>
+          <a:lstStyle/>
+          <a:p>
+            <a:pPr indent="0" marL="0">
+              <a:buNone/>
+            </a:pPr>
+            <a:r>
+              <a:rPr lang="en-US" sz="1050" dirty="0">
+                <a:solidFill>
+                  <a:srgbClr val="CFE3D8"/>
+                </a:solidFill>
+                <a:latin typeface="Calibri" pitchFamily="34" charset="0"/>
+                <a:ea typeface="Calibri" pitchFamily="34" charset="-122"/>
+                <a:cs typeface="Calibri" pitchFamily="34" charset="-120"/>
+              </a:rPr>
+              <a:t>— Adewale Odunsi, cybersecurity expert</a:t>
+            </a:r>
+            <a:endParaRPr lang="en-US" sz="1050" dirty="0"/>
+          </a:p>
+        </p:txBody>
+      </p:sp>
+      <p:sp>
+        <p:nvSpPr>
+          <p:cNvPr id="18" name="Text 16"/>
           <p:cNvSpPr/>
           <p:nvPr/>
         </p:nvSpPr>

</xml_diff>